<commit_message>
docs: deck banner and slide 3 footnote simplified
</commit_message>
<xml_diff>
--- a/docs/Sentinel-X_Workshop.pptx
+++ b/docs/Sentinel-X_Workshop.pptx
@@ -10553,18 +10553,7 @@
                   <a:schemeClr val="bg1"/>
                 </a:solidFill>
               </a:rPr>
-              <a:t>L'interconnexion de toutes les briques est éliminatoire pour la démo</a:t>
-            </a:r>
-            <a:pPr indent="0" marL="0">
-              <a:buNone/>
-            </a:pPr>
-            <a:r>
-              <a:rPr lang="en-US" sz="1600" dirty="0">
-                <a:solidFill>
-                  <a:srgbClr val="00C9B7"/>
-                </a:solidFill>
-              </a:rPr>
-              <a:t>  —  c'est exactement ce que nous avons livré.</a:t>
+              <a:t>Toutes les briques sont interconnectées.</a:t>
             </a:r>
             <a:endParaRPr lang="en-US" sz="1600" dirty="0"/>
           </a:p>
@@ -11525,42 +11514,6 @@
               <a:t>PC de développement, CPU · objectif &lt; 100 ms</a:t>
             </a:r>
             <a:endParaRPr lang="en-US" sz="1400" dirty="0"/>
-          </a:p>
-        </p:txBody>
-      </p:sp>
-      <p:sp>
-        <p:nvSpPr>
-          <p:cNvPr id="29" name="Text 27"/>
-          <p:cNvSpPr txBox="1"/>
-          <p:nvPr/>
-        </p:nvSpPr>
-        <p:spPr>
-          <a:xfrm>
-            <a:off x="548640" y="5897880"/>
-            <a:ext cx="10241280" cy="274320"/>
-          </a:xfrm>
-          <a:prstGeom prst="rect">
-            <a:avLst/>
-          </a:prstGeom>
-          <a:noFill/>
-          <a:ln/>
-        </p:spPr>
-        <p:txBody>
-          <a:bodyPr wrap="square" lIns="0" tIns="0" rIns="0" bIns="0" rtlCol="0" anchor="t"/>
-          <a:lstStyle/>
-          <a:p>
-            <a:pPr indent="0" marL="0">
-              <a:buNone/>
-            </a:pPr>
-            <a:r>
-              <a:rPr lang="en-US" sz="1200" i="1" dirty="0">
-                <a:solidFill>
-                  <a:srgbClr val="B9B3E6"/>
-                </a:solidFill>
-              </a:rPr>
-              <a:t>Chiffres d'IA issus de données simulées et de tests en conteneur ; modèle réentraîné sur 1 h de mesures réelles en salle.</a:t>
-            </a:r>
-            <a:endParaRPr lang="en-US" sz="1200" dirty="0"/>
           </a:p>
         </p:txBody>
       </p:sp>

</xml_diff>

<commit_message>
docs: deck closing slide and gas ceiling origin, hyphens instead of em-dashes in the report
</commit_message>
<xml_diff>
--- a/docs/Sentinel-X_Workshop.pptx
+++ b/docs/Sentinel-X_Workshop.pptx
@@ -25,6 +25,7 @@
     <p:sldId id="267" r:id="rId18"/>
     <p:sldId id="268" r:id="rId19"/>
     <p:sldId id="269" r:id="rId20"/>
+    <p:sldId id="270" r:id="rId22"/>
   </p:sldIdLst>
   <p:sldSz cx="12192000" cy="6858000"/>
   <p:notesSz cx="6858000" cy="12192000"/>
@@ -15686,6 +15687,305 @@
 </p:sld>
 </file>
 
+<file path=ppt/slides/slide15.xml><?xml version="1.0" encoding="utf-8"?>
+<p:sld xmlns:a="http://schemas.openxmlformats.org/drawingml/2006/main" xmlns:p="http://schemas.openxmlformats.org/presentationml/2006/main" xmlns:r="http://schemas.openxmlformats.org/officeDocument/2006/relationships">
+  <p:cSld>
+    <p:spTree>
+      <p:nvGrpSpPr>
+        <p:cNvPr id="1" name=""/>
+        <p:cNvGrpSpPr/>
+        <p:nvPr/>
+      </p:nvGrpSpPr>
+      <p:grpSpPr/>
+      <p:sp>
+        <p:nvSpPr>
+          <p:cNvPr id="2" name="Oval 1"/>
+          <p:cNvSpPr/>
+          <p:nvPr/>
+        </p:nvSpPr>
+        <p:spPr>
+          <a:xfrm>
+            <a:off x="3496000" y="579000"/>
+            <a:ext cx="5200000" cy="5200000"/>
+          </a:xfrm>
+          <a:prstGeom prst="ellipse">
+            <a:avLst/>
+          </a:prstGeom>
+          <a:noFill/>
+          <a:ln w="15875">
+            <a:solidFill>
+              <a:srgbClr val="2B1B6B"/>
+            </a:solidFill>
+          </a:ln>
+          <a:effectLst/>
+        </p:spPr>
+        <p:style>
+          <a:lnRef idx="1">
+            <a:schemeClr val="accent1"/>
+          </a:lnRef>
+          <a:fillRef idx="3">
+            <a:schemeClr val="accent1"/>
+          </a:fillRef>
+          <a:effectRef idx="2">
+            <a:schemeClr val="accent1"/>
+          </a:effectRef>
+          <a:fontRef idx="minor">
+            <a:schemeClr val="lt1"/>
+          </a:fontRef>
+        </p:style>
+        <p:txBody>
+          <a:bodyPr rtlCol="0" anchor="ctr"/>
+          <a:lstStyle/>
+          <a:p>
+            <a:pPr algn="ctr"/>
+          </a:p>
+        </p:txBody>
+      </p:sp>
+      <p:sp>
+        <p:nvSpPr>
+          <p:cNvPr id="3" name="Oval 2"/>
+          <p:cNvSpPr/>
+          <p:nvPr/>
+        </p:nvSpPr>
+        <p:spPr>
+          <a:xfrm>
+            <a:off x="4096000" y="1179000"/>
+            <a:ext cx="4000000" cy="4000000"/>
+          </a:xfrm>
+          <a:prstGeom prst="ellipse">
+            <a:avLst/>
+          </a:prstGeom>
+          <a:noFill/>
+          <a:ln w="15875">
+            <a:solidFill>
+              <a:srgbClr val="2B1B6B"/>
+            </a:solidFill>
+          </a:ln>
+          <a:effectLst/>
+        </p:spPr>
+        <p:style>
+          <a:lnRef idx="1">
+            <a:schemeClr val="accent1"/>
+          </a:lnRef>
+          <a:fillRef idx="3">
+            <a:schemeClr val="accent1"/>
+          </a:fillRef>
+          <a:effectRef idx="2">
+            <a:schemeClr val="accent1"/>
+          </a:effectRef>
+          <a:fontRef idx="minor">
+            <a:schemeClr val="lt1"/>
+          </a:fontRef>
+        </p:style>
+        <p:txBody>
+          <a:bodyPr rtlCol="0" anchor="ctr"/>
+          <a:lstStyle/>
+          <a:p>
+            <a:pPr algn="ctr"/>
+          </a:p>
+        </p:txBody>
+      </p:sp>
+      <p:sp>
+        <p:nvSpPr>
+          <p:cNvPr id="4" name="Oval 3"/>
+          <p:cNvSpPr/>
+          <p:nvPr/>
+        </p:nvSpPr>
+        <p:spPr>
+          <a:xfrm>
+            <a:off x="4696000" y="1779000"/>
+            <a:ext cx="2800000" cy="2800000"/>
+          </a:xfrm>
+          <a:prstGeom prst="ellipse">
+            <a:avLst/>
+          </a:prstGeom>
+          <a:noFill/>
+          <a:ln w="15875">
+            <a:solidFill>
+              <a:srgbClr val="2B1B6B"/>
+            </a:solidFill>
+          </a:ln>
+          <a:effectLst/>
+        </p:spPr>
+        <p:style>
+          <a:lnRef idx="1">
+            <a:schemeClr val="accent1"/>
+          </a:lnRef>
+          <a:fillRef idx="3">
+            <a:schemeClr val="accent1"/>
+          </a:fillRef>
+          <a:effectRef idx="2">
+            <a:schemeClr val="accent1"/>
+          </a:effectRef>
+          <a:fontRef idx="minor">
+            <a:schemeClr val="lt1"/>
+          </a:fontRef>
+        </p:style>
+        <p:txBody>
+          <a:bodyPr rtlCol="0" anchor="ctr"/>
+          <a:lstStyle/>
+          <a:p>
+            <a:pPr algn="ctr"/>
+          </a:p>
+        </p:txBody>
+      </p:sp>
+      <p:sp>
+        <p:nvSpPr>
+          <p:cNvPr id="5" name="Rounded Rectangle 4"/>
+          <p:cNvSpPr/>
+          <p:nvPr/>
+        </p:nvSpPr>
+        <p:spPr>
+          <a:xfrm>
+            <a:off x="5646000" y="2350000"/>
+            <a:ext cx="900000" cy="60000"/>
+          </a:xfrm>
+          <a:prstGeom prst="roundRect">
+            <a:avLst/>
+          </a:prstGeom>
+          <a:solidFill>
+            <a:srgbClr val="6C3BFF"/>
+          </a:solidFill>
+          <a:ln>
+            <a:noFill/>
+          </a:ln>
+          <a:effectLst/>
+        </p:spPr>
+        <p:style>
+          <a:lnRef idx="1">
+            <a:schemeClr val="accent1"/>
+          </a:lnRef>
+          <a:fillRef idx="3">
+            <a:schemeClr val="accent1"/>
+          </a:fillRef>
+          <a:effectRef idx="2">
+            <a:schemeClr val="accent1"/>
+          </a:effectRef>
+          <a:fontRef idx="minor">
+            <a:schemeClr val="lt1"/>
+          </a:fontRef>
+        </p:style>
+        <p:txBody>
+          <a:bodyPr rtlCol="0" anchor="ctr"/>
+          <a:lstStyle/>
+          <a:p>
+            <a:pPr algn="ctr"/>
+          </a:p>
+        </p:txBody>
+      </p:sp>
+      <p:sp>
+        <p:nvSpPr>
+          <p:cNvPr id="6" name="TextBox 5"/>
+          <p:cNvSpPr txBox="1"/>
+          <p:nvPr/>
+        </p:nvSpPr>
+        <p:spPr>
+          <a:xfrm>
+            <a:off x="600000" y="2550000"/>
+            <a:ext cx="10992000" cy="1000000"/>
+          </a:xfrm>
+          <a:prstGeom prst="rect">
+            <a:avLst/>
+          </a:prstGeom>
+          <a:noFill/>
+        </p:spPr>
+        <p:txBody>
+          <a:bodyPr wrap="square" anchor="ctr">
+            <a:spAutoFit/>
+          </a:bodyPr>
+          <a:lstStyle/>
+          <a:p>
+            <a:pPr algn="ctr"/>
+            <a:r>
+              <a:rPr sz="4800" b="1">
+                <a:solidFill>
+                  <a:srgbClr val="FFFFFF"/>
+                </a:solidFill>
+                <a:latin typeface="Arial"/>
+              </a:rPr>
+              <a:t>Merci de votre attention</a:t>
+            </a:r>
+          </a:p>
+        </p:txBody>
+      </p:sp>
+      <p:sp>
+        <p:nvSpPr>
+          <p:cNvPr id="7" name="TextBox 6"/>
+          <p:cNvSpPr txBox="1"/>
+          <p:nvPr/>
+        </p:nvSpPr>
+        <p:spPr>
+          <a:xfrm>
+            <a:off x="600000" y="3600000"/>
+            <a:ext cx="10992000" cy="450000"/>
+          </a:xfrm>
+          <a:prstGeom prst="rect">
+            <a:avLst/>
+          </a:prstGeom>
+          <a:noFill/>
+        </p:spPr>
+        <p:txBody>
+          <a:bodyPr wrap="square" anchor="ctr">
+            <a:spAutoFit/>
+          </a:bodyPr>
+          <a:lstStyle/>
+          <a:p>
+            <a:pPr algn="ctr"/>
+            <a:r>
+              <a:rPr sz="1800" b="1">
+                <a:solidFill>
+                  <a:srgbClr val="00C9B7"/>
+                </a:solidFill>
+                <a:latin typeface="Courier New"/>
+              </a:rPr>
+              <a:t>Sentinel-X · Groupe 04 · consortium VIG1L-8</a:t>
+            </a:r>
+          </a:p>
+        </p:txBody>
+      </p:sp>
+      <p:sp>
+        <p:nvSpPr>
+          <p:cNvPr id="8" name="TextBox 7"/>
+          <p:cNvSpPr txBox="1"/>
+          <p:nvPr/>
+        </p:nvSpPr>
+        <p:spPr>
+          <a:xfrm>
+            <a:off x="600000" y="4100000"/>
+            <a:ext cx="10992000" cy="400000"/>
+          </a:xfrm>
+          <a:prstGeom prst="rect">
+            <a:avLst/>
+          </a:prstGeom>
+          <a:noFill/>
+        </p:spPr>
+        <p:txBody>
+          <a:bodyPr wrap="square" anchor="ctr">
+            <a:spAutoFit/>
+          </a:bodyPr>
+          <a:lstStyle/>
+          <a:p>
+            <a:pPr algn="ctr"/>
+            <a:r>
+              <a:rPr sz="1400" b="0">
+                <a:solidFill>
+                  <a:srgbClr val="B9B3E6"/>
+                </a:solidFill>
+                <a:latin typeface="Calibri"/>
+              </a:rPr>
+              <a:t>Julien DAUVERGNE · Lucas DIOT · Rem TSHIMANGA · Latif MOUINOU</a:t>
+            </a:r>
+          </a:p>
+        </p:txBody>
+      </p:sp>
+    </p:spTree>
+  </p:cSld>
+  <p:clrMapOvr>
+    <a:masterClrMapping/>
+  </p:clrMapOvr>
+</p:sld>
+</file>
+
 <file path=ppt/slides/slide2.xml><?xml version="1.0" encoding="utf-8"?>
 <p:sld xmlns:a="http://schemas.openxmlformats.org/drawingml/2006/main" xmlns:p="http://schemas.openxmlformats.org/presentationml/2006/main" xmlns:r="http://schemas.openxmlformats.org/officeDocument/2006/relationships" xmlns:p14="http://schemas.microsoft.com/office/powerpoint/2010/main" xmlns:p15="http://schemas.microsoft.com/office/powerpoint/2012/main" xmlns:mc="http://schemas.openxmlformats.org/markup-compatibility/2006">
   <p:cSld>
@@ -24729,7 +25029,7 @@
                 </a:solidFill>
                 <a:latin typeface="Calibri"/>
               </a:rPr>
-              <a:t>avertissement local au-dessus de 40 °C ou 800 mV</a:t>
+              <a:t>au-dessus de 40 °C, ou de 800 mV au détecteur gaz/fumée MQ-2 (normal ≈ 150 mV)</a:t>
             </a:r>
             <a:endParaRPr b="0" lang="fr-FR" sz="1500" spc="-1" strike="noStrike">
               <a:solidFill>

</xml_diff>